<commit_message>
fix: calibrate Fig 12 title to F1 0.8491, synchronize guide and deck with rigorous empirical figures
</commit_message>
<xml_diff>
--- a/Diabetic_Analysis_Presentation_Bu_Yunen.pptx
+++ b/Diabetic_Analysis_Presentation_Bu_Yunen.pptx
@@ -589,13 +589,13 @@
           <a:lstStyle/>
           <a:p>
             <a:r>
-              <a:t>[ENGLISH] Slide 10 details our Bayesian hyperparameter tuning and ensemble weighting. The boxplot in Figure 05 shows that fold scores center above 85%, with individual folds reaching up to 94.81% accuracy, confirming that the consensus ensemble generalizes cleanly across subgroups.</a:t>
+              <a:t>[ENGLISH] Slide 10 details our Bayesian hyperparameter tuning and ensemble weighting. The boxplot in Figure 05 shows the fold-by-fold stability across the 4 top individual model configurations (medians between 0.83 and 0.85, peak single fold 94.81%), confirming reproducible diagnostic accuracy across patient subgroups.</a:t>
             </a:r>
           </a:p>
           <a:p/>
           <a:p>
             <a:r>
-              <a:t>[INDONESIAN] Di Slide 10 kami menyajikan tuning Bayesian Optuna dan pembobotan Consensus Ensemble. Boxplot Gambar 05 membuktikan skor tiap fold konsisten di atas 85%, dengan fold terbaik mencapai 94.81%, menandakan kestabilan model yang tinggi.</a:t>
+              <a:t>[INDONESIAN] Di Slide 10 kami menyajikan tuning Bayesian Optuna dan pembobotan Consensus Ensemble. Boxplot Gambar 05 memperlihatkan sebaran fold dari 4 model terbaik dengan median antara 0.83 hingga 0.85, dengan fold terbaik mencapai 94.81%.</a:t>
             </a:r>
           </a:p>
         </p:txBody>
@@ -665,13 +665,13 @@
           <a:lstStyle/>
           <a:p>
             <a:r>
-              <a:t>[ENGLISH] Slide 11 addresses our benchmark confrontation and includes the Consensus Confusion Matrix requested by Bu Yunen. On the 154-patient holdout test set, our Consensus Ensemble achieved 89.61% accuracy and an F1-score of 0.8519, clearing the 0.88 benchmark. As seen in the confusion matrix (Fig 12), it correctly identified 93 healthy and 45 diabetic individuals, missing 90% by just a single patient. Our 95% confidence interval spans 83.8% to 93.5%.</a:t>
+              <a:t>[ENGLISH] Slide 11 addresses our benchmark confrontation and includes the Consensus Confusion Matrix requested by Bu Yunen. On the 154-patient holdout test set, our Consensus Ensemble achieved 89.61% accuracy and an F1-score of 0.8491, clearing the 0.88 benchmark on this split. As seen in the confusion matrix (Fig 12), it correctly identified 93 healthy and 45 diabetic individuals, missing 90% by just a single patient. Our 95% confidence interval spans 83.8% to 93.5%, while our 10-fold cross-validation average is 85.28%.</a:t>
             </a:r>
           </a:p>
           <a:p/>
           <a:p>
             <a:r>
-              <a:t>[INDONESIAN] Di Slide 11 ini, kita sajikan perbandingan benchmark (Gambar 03) dan Confusion Matrix Consensus Ensemble (Gambar 12) sesuai permintaan Bu Yunen. Pada data uji holdout 154 pasien, model consensus kita mencetak akurasi 89.61% dan F1-score 0.8519, berhasil melewati benchmark kakak kelas (0.88). Model mendiagnosa 93 pasien sehat dan 45 pasien diabetes secara akurat, hanya berjarak 1 pasien saja dari angka 90%.</a:t>
+              <a:t>[INDONESIAN] Di Slide 11 ini, kita sajikan perbandingan benchmark (Gambar 03) dan Confusion Matrix Consensus Ensemble (Gambar 12) sesuai permintaan Bu Yunen. Pada data uji holdout 154 pasien, model consensus kita mencetak akurasi 89.61% dan F1-score 0.8491, berhasil melewati benchmark kakak kelas (0.88) pada split ini. Model mendiagnosa 93 pasien sehat dan 45 pasien diabetes secara akurat, hanya berjarak 1 pasien saja dari angka 90%. Rentang CI 95% kita berada di 83.8% - 93.5%, dengan rerata 10-fold CV di 85.28%.</a:t>
             </a:r>
           </a:p>
         </p:txBody>
@@ -4565,7 +4565,7 @@
               </a:defRPr>
             </a:pPr>
             <a:r>
-              <a:t>• Cleared Upperclassmen Benchmark: 89.61% Holdout Accuracy &amp; 0.8519 F1-Score (clearing prior 0.8800 peak by +1.61 pp).</a:t>
+              <a:t>• Cleared Upperclassmen Benchmark: 89.61% Holdout Accuracy &amp; 0.8491 F1-Score (clearing prior 0.8800 peak by +1.61 pp).</a:t>
             </a:r>
             <a:br/>
             <a:r>
@@ -4778,11 +4778,11 @@
               </a:defRPr>
             </a:pPr>
             <a:r>
-              <a:t>• Fold Distribution (Boxplot):</a:t>
+              <a:t>• Fold Distribution (Boxplot Fig 05):</a:t>
             </a:r>
             <a:br/>
             <a:r>
-              <a:t>  - Mean 10-Fold CV: 0.8528</a:t>
+              <a:t>  - 4 top model medians: 0.831 to 0.850</a:t>
             </a:r>
             <a:br/>
             <a:r>
@@ -4790,7 +4790,7 @@
             </a:r>
             <a:br/>
             <a:r>
-              <a:t>  - Tight interquartile range proves stability across all patient subgroups.</a:t>
+              <a:t>  - Consensus Ensemble 10-Fold CV Mean: 0.8528</a:t>
             </a:r>
           </a:p>
         </p:txBody>

</xml_diff>